<commit_message>
Connect the public film and polish the reviewer package
</commit_message>
<xml_diff>
--- a/docs/presentation/ASTERION-Pitch.en-2026-10-27.pptx
+++ b/docs/presentation/ASTERION-Pitch.en-2026-10-27.pptx
@@ -2,22 +2,22 @@
 <file path=ppt/presentation.xml><?xml version="1.0" encoding="utf-8"?>
 <p:presentation xmlns:p="http://schemas.openxmlformats.org/presentationml/2006/main">
   <p:sldMasterIdLst>
-    <p:sldMasterId xmlns:r="http://schemas.openxmlformats.org/officeDocument/2006/relationships" id="2147483648" r:id="R38fa8846dc5249cc"/>
+    <p:sldMasterId xmlns:r="http://schemas.openxmlformats.org/officeDocument/2006/relationships" id="2147483648" r:id="Raefd3e82de204b37"/>
   </p:sldMasterIdLst>
   <p:notesMasterIdLst>
-    <p:notesMasterId xmlns:r="http://schemas.openxmlformats.org/officeDocument/2006/relationships" r:id="Re4205e78a549467c"/>
+    <p:notesMasterId xmlns:r="http://schemas.openxmlformats.org/officeDocument/2006/relationships" r:id="R9605f4e708474ca6"/>
   </p:notesMasterIdLst>
   <p:sldIdLst>
-    <p:sldId xmlns:r="http://schemas.openxmlformats.org/officeDocument/2006/relationships" id="256" r:id="Rf96502f2e63746a5"/>
-    <p:sldId xmlns:r="http://schemas.openxmlformats.org/officeDocument/2006/relationships" id="257" r:id="Rd4510ea1064447e8"/>
-    <p:sldId xmlns:r="http://schemas.openxmlformats.org/officeDocument/2006/relationships" id="258" r:id="R05802cc6d4ab4f30"/>
-    <p:sldId xmlns:r="http://schemas.openxmlformats.org/officeDocument/2006/relationships" id="259" r:id="R8dee10aaf438423c"/>
-    <p:sldId xmlns:r="http://schemas.openxmlformats.org/officeDocument/2006/relationships" id="260" r:id="R69f1bc02e88a49b2"/>
-    <p:sldId xmlns:r="http://schemas.openxmlformats.org/officeDocument/2006/relationships" id="261" r:id="Rfa96d6c723a24c87"/>
-    <p:sldId xmlns:r="http://schemas.openxmlformats.org/officeDocument/2006/relationships" id="262" r:id="R8054d836b88e4065"/>
-    <p:sldId xmlns:r="http://schemas.openxmlformats.org/officeDocument/2006/relationships" id="263" r:id="Re61c7f4249084d8c"/>
-    <p:sldId xmlns:r="http://schemas.openxmlformats.org/officeDocument/2006/relationships" id="264" r:id="R0a0c4ff507534d55"/>
-    <p:sldId xmlns:r="http://schemas.openxmlformats.org/officeDocument/2006/relationships" id="265" r:id="R570f3459acf947aa"/>
+    <p:sldId xmlns:r="http://schemas.openxmlformats.org/officeDocument/2006/relationships" id="256" r:id="R1f93bcaf82b641a1"/>
+    <p:sldId xmlns:r="http://schemas.openxmlformats.org/officeDocument/2006/relationships" id="257" r:id="R6c74b7a887e048e5"/>
+    <p:sldId xmlns:r="http://schemas.openxmlformats.org/officeDocument/2006/relationships" id="258" r:id="R528c6df830e3415e"/>
+    <p:sldId xmlns:r="http://schemas.openxmlformats.org/officeDocument/2006/relationships" id="259" r:id="R1d87bb0541724778"/>
+    <p:sldId xmlns:r="http://schemas.openxmlformats.org/officeDocument/2006/relationships" id="260" r:id="Ref2ece0b785749b1"/>
+    <p:sldId xmlns:r="http://schemas.openxmlformats.org/officeDocument/2006/relationships" id="261" r:id="Ra801fd3059ca46b2"/>
+    <p:sldId xmlns:r="http://schemas.openxmlformats.org/officeDocument/2006/relationships" id="262" r:id="Rdf43a4edb7b9494d"/>
+    <p:sldId xmlns:r="http://schemas.openxmlformats.org/officeDocument/2006/relationships" id="263" r:id="R4531a4228c2643f3"/>
+    <p:sldId xmlns:r="http://schemas.openxmlformats.org/officeDocument/2006/relationships" id="264" r:id="R8bfaf1bdbd2841b3"/>
+    <p:sldId xmlns:r="http://schemas.openxmlformats.org/officeDocument/2006/relationships" id="265" r:id="R0c5d24558b5741c5"/>
   </p:sldIdLst>
   <p:sldSz cx="12192000" cy="6858000"/>
   <p:notesSz cx="6858000" cy="9144000"/>
@@ -581,7 +581,7 @@
           </a:p>
           <a:p xmlns:a="http://schemas.openxmlformats.org/drawingml/2006/main">
             <a:r>
-              <a:t>The hackathon requires meaningful use of PayPal and AI. Submission materials need English or an English translation. The current delivery checklist records a cutoff of November 12, 2026 at 12:00 PST, or 20:00 Canary Islands time. Registration, personal eligibility and final submission still require completion. A final public YouTube demonstration under three minutes remains pending. This presentation does not submit the project or guarantee an award.</a:t>
+              <a:t>The hackathon requires meaningful use of PayPal and AI. Submission materials need English or an English translation. The current delivery checklist records a cutoff of November 12, 2026 at 12:00 PST, or 20:00 Canary Islands time. Registration, personal eligibility and final submission still require completion. The owner supplied the selected 165-second YouTube demonstration on 28 October 2026: https://www.youtube.com/watch?v=l_cS_-SIsdQ. This presentation does not submit the project or guarantee an award.</a:t>
             </a:r>
           </a:p>
           <a:p xmlns:a="http://schemas.openxmlformats.org/drawingml/2006/main">
@@ -1131,7 +1131,7 @@
           </a:p>
           <a:p xmlns:a="http://schemas.openxmlformats.org/drawingml/2006/main">
             <a:r>
-              <a:t>The receipt visualization summarizes internal consistency. The real MET Norway model forecast supports read-only planning. Complete local observations and actual operators remain the next field milestone. The film and any human-voice comparison await owner review before public YouTube publication.</a:t>
+              <a:t>The receipt visualization summarizes internal consistency. The real MET Norway model forecast supports read-only planning. Complete local observations and actual operators remain the next field milestone. After comparing both narration versions, the owner selected the original neural film on 28 October 2026. The supplied YouTube demonstration is https://www.youtube.com/watch?v=l_cS_-SIsdQ.</a:t>
             </a:r>
           </a:p>
           <a:p xmlns:a="http://schemas.openxmlformats.org/drawingml/2006/main">
@@ -1396,7 +1396,7 @@
           </a:p>
           <a:p xmlns:a="http://schemas.openxmlformats.org/drawingml/2006/main">
             <a:r>
-              <a:t>26 October 2026 update: browser receipt downloads now retain the full receipt payload. An HTTP regression verifies both settled and voided receipts through the frontend API client. CI: https://github.com/Enrickq/asterion-commerce/actions/runs/40310939358. These code fixes do not create new private PayPal or Gemini verification runs. The new local 165-second launch film combines actual captured application steps, original motion graphics and score, an illustrated La Palma landscape and local neural narration. Owner review, a comparison with the founder’s own voice, and public YouTube upload remain pending. These media revisions do not create new private Gemini or PayPal verification runs.</a:t>
+              <a:t>26 October 2026 update: browser receipt downloads now retain the full receipt payload. An HTTP regression verifies both settled and voided receipts through the frontend API client. CI: https://github.com/Enrickq/asterion-commerce/actions/runs/40310939358. These code fixes do not create new private PayPal or Gemini verification runs. The new local 165-second launch film combines actual captured application steps, original motion graphics and score, an illustrated La Palma landscape and local neural narration. After comparing both narration versions, the owner selected the original neural film and supplied its YouTube link on 28 October 2026: https://www.youtube.com/watch?v=l_cS_-SIsdQ. These media revisions do not create new private Gemini or PayPal verification runs.</a:t>
             </a:r>
           </a:p>
         </p:txBody>
@@ -3939,12 +3939,12 @@
   </p:cSld>
   <p:clrMap bg1="lt1" tx1="dk1" bg2="lt2" tx2="dk2" accent1="accent1" accent2="accent2" accent3="accent3" accent4="accent4" accent5="accent5" accent6="accent6" hlink="hlink" folHlink="folHlink"/>
   <p:sldLayoutIdLst>
-    <p:sldLayoutId xmlns:r="http://schemas.openxmlformats.org/officeDocument/2006/relationships" id="2147483649" r:id="R2e59c21b043847f2"/>
-    <p:sldLayoutId xmlns:r="http://schemas.openxmlformats.org/officeDocument/2006/relationships" id="2147483650" r:id="Rede68bb686fd4d0f"/>
-    <p:sldLayoutId xmlns:r="http://schemas.openxmlformats.org/officeDocument/2006/relationships" id="2147483651" r:id="R3b0a66ee7f534e85"/>
-    <p:sldLayoutId xmlns:r="http://schemas.openxmlformats.org/officeDocument/2006/relationships" id="2147483652" r:id="Rb7f4f77e1c6e414d"/>
-    <p:sldLayoutId xmlns:r="http://schemas.openxmlformats.org/officeDocument/2006/relationships" id="2147483653" r:id="R445ce4de2bfc4486"/>
-    <p:sldLayoutId xmlns:r="http://schemas.openxmlformats.org/officeDocument/2006/relationships" id="2147483654" r:id="R431cccbeacd9486d"/>
+    <p:sldLayoutId xmlns:r="http://schemas.openxmlformats.org/officeDocument/2006/relationships" id="2147483649" r:id="R56fc1c65d42c415b"/>
+    <p:sldLayoutId xmlns:r="http://schemas.openxmlformats.org/officeDocument/2006/relationships" id="2147483650" r:id="Rc44616d039ca4fc1"/>
+    <p:sldLayoutId xmlns:r="http://schemas.openxmlformats.org/officeDocument/2006/relationships" id="2147483651" r:id="R9e30a7bb645f4514"/>
+    <p:sldLayoutId xmlns:r="http://schemas.openxmlformats.org/officeDocument/2006/relationships" id="2147483652" r:id="R20573653533c411f"/>
+    <p:sldLayoutId xmlns:r="http://schemas.openxmlformats.org/officeDocument/2006/relationships" id="2147483653" r:id="R83480998317e4bb6"/>
+    <p:sldLayoutId xmlns:r="http://schemas.openxmlformats.org/officeDocument/2006/relationships" id="2147483654" r:id="R425ab4b7c5bf4897"/>
   </p:sldLayoutIdLst>
   <p:txStyles>
     <p:titleStyle>
@@ -5860,7 +5860,7 @@
           <p:cNvPr id="3" name="">
             <a:extLst xmlns:a="http://schemas.openxmlformats.org/drawingml/2006/main">
               <a:ext uri="{FF2B5EF4-FFF2-40B4-BE49-F238E27FC236}">
-                <a16:creationId xmlns:a16="http://schemas.microsoft.com/office/drawing/2014/main" id="{E78CB996-75C4-4E98-80DA-9C72A93B078A}"/>
+                <a16:creationId xmlns:a16="http://schemas.microsoft.com/office/drawing/2014/main" id="{BDE490E4-A282-496A-9DBF-0E7D459498BC}"/>
               </a:ext>
             </a:extLst>
           </p:cNvPr>
@@ -6600,7 +6600,7 @@
             <a:defPPr>
               <a:defRPr sz="1425" b="0">
                 <a:solidFill>
-                  <a:srgbClr val="A6BAC1"/>
+                  <a:srgbClr val="A8EDD8"/>
                 </a:solidFill>
                 <a:latin typeface="Arial"/>
                 <a:ea typeface="Arial"/>
@@ -6712,7 +6712,7 @@
               <a:buNone/>
               <a:defRPr sz="1425" b="0">
                 <a:solidFill>
-                  <a:srgbClr val="A6BAC1"/>
+                  <a:srgbClr val="A8EDD8"/>
                 </a:solidFill>
                 <a:latin typeface="Arial"/>
                 <a:ea typeface="Arial"/>
@@ -6722,13 +6722,60 @@
             <a:r>
               <a:rPr sz="1425" b="0">
                 <a:solidFill>
-                  <a:srgbClr val="A6BAC1"/>
-                </a:solidFill>
-                <a:latin typeface="Arial"/>
-                <a:ea typeface="Arial"/>
-                <a:cs typeface="Arial"/>
+                  <a:srgbClr val="A8EDD8"/>
+                </a:solidFill>
+                <a:latin typeface="Arial"/>
+                <a:ea typeface="Arial"/>
+                <a:cs typeface="Arial"/>
+                <a:hlinkClick xmlns:r="http://schemas.openxmlformats.org/officeDocument/2006/relationships" r:id="R6b97a18b68f047a3"/>
               </a:rPr>
-              <a:t>asterion-mj13.onrender.com     github.com/Enrickq/asterion-commerce</a:t>
+              <a:t>Try the demo</a:t>
+            </a:r>
+            <a:r>
+              <a:rPr sz="1425" b="0">
+                <a:solidFill>
+                  <a:srgbClr val="A8EDD8"/>
+                </a:solidFill>
+                <a:latin typeface="Arial"/>
+                <a:ea typeface="Arial"/>
+                <a:cs typeface="Arial"/>
+              </a:rPr>
+              <a:t>     </a:t>
+            </a:r>
+            <a:r>
+              <a:rPr sz="1425" b="0">
+                <a:solidFill>
+                  <a:srgbClr val="A8EDD8"/>
+                </a:solidFill>
+                <a:latin typeface="Arial"/>
+                <a:ea typeface="Arial"/>
+                <a:cs typeface="Arial"/>
+                <a:hlinkClick xmlns:r="http://schemas.openxmlformats.org/officeDocument/2006/relationships" r:id="Rc422b3b8c18c40ad"/>
+              </a:rPr>
+              <a:t>Inspect the code</a:t>
+            </a:r>
+            <a:r>
+              <a:rPr sz="1425" b="0">
+                <a:solidFill>
+                  <a:srgbClr val="A8EDD8"/>
+                </a:solidFill>
+                <a:latin typeface="Arial"/>
+                <a:ea typeface="Arial"/>
+                <a:cs typeface="Arial"/>
+              </a:rPr>
+              <a:t>     </a:t>
+            </a:r>
+            <a:r>
+              <a:rPr sz="1425" b="0">
+                <a:solidFill>
+                  <a:srgbClr val="A8EDD8"/>
+                </a:solidFill>
+                <a:latin typeface="Arial"/>
+                <a:ea typeface="Arial"/>
+                <a:cs typeface="Arial"/>
+                <a:hlinkClick xmlns:r="http://schemas.openxmlformats.org/officeDocument/2006/relationships" r:id="R5774cbec5bb4419f"/>
+              </a:rPr>
+              <a:t>Watch the 2:45 film</a:t>
             </a:r>
           </a:p>
         </p:txBody>
@@ -9158,7 +9205,7 @@
           <p:cNvPr id="7" name="">
             <a:extLst xmlns:a="http://schemas.openxmlformats.org/drawingml/2006/main">
               <a:ext uri="{FF2B5EF4-FFF2-40B4-BE49-F238E27FC236}">
-                <a16:creationId xmlns:a16="http://schemas.microsoft.com/office/drawing/2014/main" id="{A5DE8161-8206-4675-9CDC-2564B6874B27}"/>
+                <a16:creationId xmlns:a16="http://schemas.microsoft.com/office/drawing/2014/main" id="{4EAB1791-56F7-4A72-85CA-CF11058878C4}"/>
               </a:ext>
             </a:extLst>
           </p:cNvPr>
@@ -10208,7 +10255,7 @@
           <p:cNvPr id="3" name="">
             <a:extLst xmlns:a="http://schemas.openxmlformats.org/drawingml/2006/main">
               <a:ext uri="{FF2B5EF4-FFF2-40B4-BE49-F238E27FC236}">
-                <a16:creationId xmlns:a16="http://schemas.microsoft.com/office/drawing/2014/main" id="{71E8829B-0983-48C4-9AC8-EB7456C59F47}"/>
+                <a16:creationId xmlns:a16="http://schemas.microsoft.com/office/drawing/2014/main" id="{34AE8AAC-C376-4DB2-B7E9-12A4F32D8D01}"/>
               </a:ext>
             </a:extLst>
           </p:cNvPr>
@@ -11425,7 +11472,7 @@
           <p:cNvPr id="3" name="">
             <a:extLst xmlns:a="http://schemas.openxmlformats.org/drawingml/2006/main">
               <a:ext uri="{FF2B5EF4-FFF2-40B4-BE49-F238E27FC236}">
-                <a16:creationId xmlns:a16="http://schemas.microsoft.com/office/drawing/2014/main" id="{8947F047-3414-4D22-B002-26D7857D95D3}"/>
+                <a16:creationId xmlns:a16="http://schemas.microsoft.com/office/drawing/2014/main" id="{2A175670-3CAC-49FE-B4B6-704FDFE50877}"/>
               </a:ext>
             </a:extLst>
           </p:cNvPr>
@@ -12814,7 +12861,7 @@
           <p:cNvPr id="3" name="">
             <a:extLst xmlns:a="http://schemas.openxmlformats.org/drawingml/2006/main">
               <a:ext uri="{FF2B5EF4-FFF2-40B4-BE49-F238E27FC236}">
-                <a16:creationId xmlns:a16="http://schemas.microsoft.com/office/drawing/2014/main" id="{8BABEBDF-6288-45EE-B208-12960D67FC09}"/>
+                <a16:creationId xmlns:a16="http://schemas.microsoft.com/office/drawing/2014/main" id="{AA4F2D00-9BC6-4621-9C5C-4C49906B2043}"/>
               </a:ext>
             </a:extLst>
           </p:cNvPr>
@@ -14394,7 +14441,7 @@
           <p:cNvPr id="4" name="">
             <a:extLst xmlns:a="http://schemas.openxmlformats.org/drawingml/2006/main">
               <a:ext uri="{FF2B5EF4-FFF2-40B4-BE49-F238E27FC236}">
-                <a16:creationId xmlns:a16="http://schemas.microsoft.com/office/drawing/2014/main" id="{83BD654A-CC03-484E-BCD6-06411552105D}"/>
+                <a16:creationId xmlns:a16="http://schemas.microsoft.com/office/drawing/2014/main" id="{33FB17BA-893A-4D08-A2E3-B405FD8EFE2A}"/>
               </a:ext>
             </a:extLst>
           </p:cNvPr>
@@ -15284,7 +15331,7 @@
           <p:cNvPr id="3" name="">
             <a:extLst xmlns:a="http://schemas.openxmlformats.org/drawingml/2006/main">
               <a:ext uri="{FF2B5EF4-FFF2-40B4-BE49-F238E27FC236}">
-                <a16:creationId xmlns:a16="http://schemas.microsoft.com/office/drawing/2014/main" id="{D6C101BF-A93B-4CAD-AD8C-FE4CAD66ED13}"/>
+                <a16:creationId xmlns:a16="http://schemas.microsoft.com/office/drawing/2014/main" id="{360432AC-C833-45A2-9B72-D65D3A74B50F}"/>
               </a:ext>
             </a:extLst>
           </p:cNvPr>
@@ -15294,7 +15341,7 @@
           <p:nvPr/>
         </p:nvPicPr>
         <p:blipFill>
-          <a:blip xmlns:r="http://schemas.openxmlformats.org/officeDocument/2006/relationships" xmlns:a="http://schemas.openxmlformats.org/drawingml/2006/main" r:embed="R59eebe71ceab46f7"/>
+          <a:blip xmlns:r="http://schemas.openxmlformats.org/officeDocument/2006/relationships" xmlns:a="http://schemas.openxmlformats.org/drawingml/2006/main" r:embed="R139798e005b34914"/>
           <a:stretch xmlns:a="http://schemas.openxmlformats.org/drawingml/2006/main"/>
         </p:blipFill>
         <p:spPr>

</xml_diff>